<commit_message>
add adoption convergence + small slides edits
</commit_message>
<xml_diff>
--- a/european_values/presentation/eu_ai_scenarios.pptx
+++ b/european_values/presentation/eu_ai_scenarios.pptx
@@ -22,6 +22,7 @@
     <p:sldId id="270" r:id="rId16"/>
     <p:sldId id="271" r:id="rId17"/>
     <p:sldId id="272" r:id="rId18"/>
+    <p:sldId id="273" r:id="rId19"/>
   </p:sldIdLst>
   <p:sldSz cx="9144000" cy="5143500" type="screen16x9"/>
   <p:notesSz cx="6858000" cy="9144000"/>
@@ -3812,6 +3813,88 @@
             </a:pPr>
             <a:r>
               <a:rPr/>
+              <a:t>What if Europe caught up on adoption?</a:t>
+            </a:r>
+          </a:p>
+        </p:txBody>
+      </p:sp>
+      <p:pic>
+        <p:nvPicPr>
+          <p:cNvPr descr="../output/figures/convergence.png" id="0" name="Picture 1"/>
+          <p:cNvPicPr>
+            <a:picLocks noGrp="1" noChangeAspect="1"/>
+          </p:cNvPicPr>
+          <p:nvPr/>
+        </p:nvPicPr>
+        <p:blipFill>
+          <a:blip r:embed="rId2"/>
+          <a:stretch>
+            <a:fillRect/>
+          </a:stretch>
+        </p:blipFill>
+        <p:spPr bwMode="auto">
+          <a:xfrm>
+            <a:off x="609600" y="1193800"/>
+            <a:ext cx="7937500" cy="3175000"/>
+          </a:xfrm>
+          <a:prstGeom prst="rect">
+            <a:avLst/>
+          </a:prstGeom>
+          <a:noFill/>
+          <a:ln w="9525">
+            <a:noFill/>
+            <a:headEnd/>
+            <a:tailEnd/>
+          </a:ln>
+        </p:spPr>
+      </p:pic>
+    </p:spTree>
+  </p:cSld>
+</p:sld>
+</file>
+
+<file path=ppt/slides/slide17.xml><?xml version="1.0" encoding="utf-8"?>
+<p:sld xmlns:a="http://schemas.openxmlformats.org/drawingml/2006/main" xmlns:r="http://schemas.openxmlformats.org/officeDocument/2006/relationships" xmlns:p="http://schemas.openxmlformats.org/presentationml/2006/main">
+  <p:cSld>
+    <p:spTree>
+      <p:nvGrpSpPr>
+        <p:cNvPr id="1" name=""/>
+        <p:cNvGrpSpPr/>
+        <p:nvPr/>
+      </p:nvGrpSpPr>
+      <p:grpSpPr>
+        <a:xfrm>
+          <a:off x="0" y="0"/>
+          <a:ext cx="0" cy="0"/>
+          <a:chOff x="0" y="0"/>
+          <a:chExt cx="0" cy="0"/>
+        </a:xfrm>
+      </p:grpSpPr>
+      <p:sp>
+        <p:nvSpPr>
+          <p:cNvPr id="2" name="Title 1"/>
+          <p:cNvSpPr>
+            <a:spLocks noGrp="1"/>
+          </p:cNvSpPr>
+          <p:nvPr>
+            <p:ph type="title"/>
+          </p:nvPr>
+        </p:nvSpPr>
+        <p:spPr>
+          <a:xfrm>
+            <a:off x="457200" y="205979"/>
+            <a:ext cx="8229600" cy="857250"/>
+          </a:xfrm>
+        </p:spPr>
+        <p:txBody>
+          <a:bodyPr/>
+          <a:lstStyle/>
+          <a:p>
+            <a:pPr lvl="0" indent="0" marL="0">
+              <a:buNone/>
+            </a:pPr>
+            <a:r>
+              <a:rPr/>
               <a:t>Takeaways</a:t>
             </a:r>
           </a:p>
@@ -3835,7 +3918,7 @@
             <a:pPr lvl="0"/>
             <a:r>
               <a:rPr/>
-              <a:t>Same AI, European labour market: </a:t>
+              <a:t>Same scenarios in European labour market: </a:t>
             </a:r>
             <a:r>
               <a:rPr b="1"/>
@@ -3846,14 +3929,14 @@
             <a:pPr lvl="1"/>
             <a:r>
               <a:rPr/>
-              <a:t>stickier cognitive wages and slower hiring turn wage cuts into job losses</a:t>
+              <a:t>stickier wages + slower hiring turn wage cuts into job losses</a:t>
             </a:r>
           </a:p>
           <a:p>
             <a:pPr lvl="0"/>
             <a:r>
               <a:rPr/>
-              <a:t>Our European scenarios: </a:t>
+              <a:t>Different European scenarios: </a:t>
             </a:r>
             <a:r>
               <a:rPr b="1"/>
@@ -3871,40 +3954,42 @@
             <a:pPr lvl="1"/>
             <a:r>
               <a:rPr/>
-              <a:t>most of the gap is </a:t>
-            </a:r>
-            <a:r>
-              <a:rPr b="1"/>
-              <a:t>adoption</a:t>
-            </a:r>
+              <a:t>most of the gap is adoption: Europe starts lower and does not catch up</a:t>
+            </a:r>
+          </a:p>
+          <a:p>
+            <a:pPr lvl="0"/>
             <a:r>
               <a:rPr/>
-              <a:t>: Europe starts lower and does not catch up</a:t>
+              <a:t>Adoption as an important lever</a:t>
+            </a:r>
+          </a:p>
+          <a:p>
+            <a:pPr lvl="1"/>
+            <a:r>
+              <a:rPr/>
+              <a:t>catching up with US adoption by 2030: gains up by two thirds, cognitive wages still rise</a:t>
+            </a:r>
+          </a:p>
+          <a:p>
+            <a:pPr lvl="1"/>
+            <a:r>
+              <a:rPr/>
+              <a:t>but in the extreme scenario unemployment then approaches the US level</a:t>
+            </a:r>
+          </a:p>
+          <a:p>
+            <a:pPr lvl="1"/>
+            <a:r>
+              <a:rPr/>
+              <a:t>ongoing work on why adoption differs so much across countries</a:t>
             </a:r>
           </a:p>
           <a:p>
             <a:pPr lvl="0"/>
             <a:r>
               <a:rPr/>
-              <a:t>Adoption is the lever</a:t>
-            </a:r>
-          </a:p>
-          <a:p>
-            <a:pPr lvl="1"/>
-            <a:r>
-              <a:rPr/>
-              <a:t>ongoing work on why adoption is lower and differs across countries</a:t>
-            </a:r>
-          </a:p>
-          <a:p>
-            <a:pPr lvl="0"/>
-            <a:r>
-              <a:rPr/>
-              <a:t>The parameters are </a:t>
-            </a:r>
-            <a:r>
-              <a:rPr b="1"/>
-              <a:t>uncertain and open for debate</a:t>
+              <a:t>These parameters are uncertain and open for debate</a:t>
             </a:r>
           </a:p>
           <a:p>
@@ -3921,7 +4006,7 @@
 </p:sld>
 </file>
 
-<file path=ppt/slides/slide17.xml><?xml version="1.0" encoding="utf-8"?>
+<file path=ppt/slides/slide18.xml><?xml version="1.0" encoding="utf-8"?>
 <p:sld xmlns:a="http://schemas.openxmlformats.org/drawingml/2006/main" xmlns:r="http://schemas.openxmlformats.org/officeDocument/2006/relationships" xmlns:p="http://schemas.openxmlformats.org/presentationml/2006/main">
   <p:cSld>
     <p:bg>
@@ -4866,7 +4951,7 @@
             <a:pPr lvl="0"/>
             <a:r>
               <a:rPr/>
-              <a:t>We build on their model in two ways:</a:t>
+              <a:t>We change their model in two ways:</a:t>
             </a:r>
           </a:p>
           <a:p>
@@ -4888,15 +4973,22 @@
             </a:r>
             <a:r>
               <a:rPr/>
-              <a:t> (and </a:t>
+              <a:t> and </a:t>
             </a:r>
             <a:r>
               <a:rPr i="1"/>
-              <a:t>will</a:t>
+              <a:t>will be able to</a:t>
             </a:r>
             <a:r>
               <a:rPr/>
-              <a:t>) do</a:t>
+              <a:t> do</a:t>
+            </a:r>
+          </a:p>
+          <a:p>
+            <a:pPr lvl="2"/>
+            <a:r>
+              <a:rPr/>
+              <a:t>disclaimer: scenarios to explore and not forecasts</a:t>
             </a:r>
           </a:p>
         </p:txBody>
@@ -5021,8 +5113,8 @@
         </p:blipFill>
         <p:spPr bwMode="auto">
           <a:xfrm>
-            <a:off x="774700" y="1193800"/>
-            <a:ext cx="7594600" cy="3175000"/>
+            <a:off x="939800" y="1193800"/>
+            <a:ext cx="7264400" cy="3175000"/>
           </a:xfrm>
           <a:prstGeom prst="rect">
             <a:avLst/>
@@ -5134,7 +5226,7 @@
             </a:pPr>
             <a:r>
               <a:rPr/>
-              <a:t>What each scenario sets for 2030</a:t>
+              <a:t>What Scenarios Set for 2030</a:t>
             </a:r>
           </a:p>
         </p:txBody>
@@ -5174,6 +5266,32 @@
                       </a:pPr>
                       <a:r>
                         <a:rPr b="1"/>
+                        <a:t>Use of AI</a:t>
+                      </a:r>
+                    </a:p>
+                  </a:txBody>
+                </a:tc>
+                <a:tc>
+                  <a:txBody>
+                    <a:bodyPr/>
+                    <a:lstStyle/>
+                    <a:p>
+                      <a:endParaRPr/>
+                    </a:p>
+                  </a:txBody>
+                </a:tc>
+              </a:tr>
+              <a:tr h="0">
+                <a:tc>
+                  <a:txBody>
+                    <a:bodyPr/>
+                    <a:lstStyle/>
+                    <a:p>
+                      <a:pPr lvl="0" indent="0" marL="0">
+                        <a:buNone/>
+                      </a:pPr>
+                      <a:r>
+                        <a:rPr/>
                         <a:t>Capability</a:t>
                       </a:r>
                     </a:p>
@@ -5205,7 +5323,7 @@
                         <a:buNone/>
                       </a:pPr>
                       <a:r>
-                        <a:rPr b="1"/>
+                        <a:rPr/>
                         <a:t>Adoption</a:t>
                       </a:r>
                     </a:p>
@@ -5238,6 +5356,32 @@
                       </a:pPr>
                       <a:r>
                         <a:rPr b="1"/>
+                        <a:t>Effect on tasks</a:t>
+                      </a:r>
+                    </a:p>
+                  </a:txBody>
+                </a:tc>
+                <a:tc>
+                  <a:txBody>
+                    <a:bodyPr/>
+                    <a:lstStyle/>
+                    <a:p>
+                      <a:endParaRPr/>
+                    </a:p>
+                  </a:txBody>
+                </a:tc>
+              </a:tr>
+              <a:tr h="0">
+                <a:tc>
+                  <a:txBody>
+                    <a:bodyPr/>
+                    <a:lstStyle/>
+                    <a:p>
+                      <a:pPr lvl="0" indent="0" marL="0">
+                        <a:buNone/>
+                      </a:pPr>
+                      <a:r>
+                        <a:rPr/>
                         <a:t>Automation</a:t>
                       </a:r>
                     </a:p>
@@ -5269,7 +5413,7 @@
                         <a:buNone/>
                       </a:pPr>
                       <a:r>
-                        <a:rPr b="1"/>
+                        <a:rPr/>
                         <a:t>New tasks</a:t>
                       </a:r>
                     </a:p>
@@ -5301,7 +5445,7 @@
                         <a:buNone/>
                       </a:pPr>
                       <a:r>
-                        <a:rPr b="1"/>
+                        <a:rPr/>
                         <a:t>Gain per task</a:t>
                       </a:r>
                     </a:p>
@@ -5333,7 +5477,97 @@
                         <a:buNone/>
                       </a:pPr>
                       <a:r>
-                        <a:rPr i="1"/>
+                        <a:rPr b="1"/>
+                        <a:t>Finding new jobs</a:t>
+                      </a:r>
+                    </a:p>
+                  </a:txBody>
+                </a:tc>
+                <a:tc>
+                  <a:txBody>
+                    <a:bodyPr/>
+                    <a:lstStyle/>
+                    <a:p>
+                      <a:endParaRPr/>
+                    </a:p>
+                  </a:txBody>
+                </a:tc>
+              </a:tr>
+              <a:tr h="0">
+                <a:tc>
+                  <a:txBody>
+                    <a:bodyPr/>
+                    <a:lstStyle/>
+                    <a:p>
+                      <a:pPr lvl="0" indent="0" marL="0">
+                        <a:buNone/>
+                      </a:pPr>
+                      <a:r>
+                        <a:rPr/>
+                        <a:t>Switching</a:t>
+                      </a:r>
+                    </a:p>
+                  </a:txBody>
+                </a:tc>
+                <a:tc>
+                  <a:txBody>
+                    <a:bodyPr/>
+                    <a:lstStyle/>
+                    <a:p>
+                      <a:pPr lvl="0" indent="0" marL="0">
+                        <a:buNone/>
+                      </a:pPr>
+                      <a:r>
+                        <a:rPr/>
+                        <a:t>how easily displaced workers get hired in other jobs</a:t>
+                      </a:r>
+                    </a:p>
+                  </a:txBody>
+                </a:tc>
+              </a:tr>
+              <a:tr h="0">
+                <a:tc>
+                  <a:txBody>
+                    <a:bodyPr/>
+                    <a:lstStyle/>
+                    <a:p>
+                      <a:pPr lvl="0" indent="0" marL="0">
+                        <a:buNone/>
+                      </a:pPr>
+                      <a:r>
+                        <a:rPr/>
+                        <a:t>Hiring speed</a:t>
+                      </a:r>
+                    </a:p>
+                  </a:txBody>
+                </a:tc>
+                <a:tc>
+                  <a:txBody>
+                    <a:bodyPr/>
+                    <a:lstStyle/>
+                    <a:p>
+                      <a:pPr lvl="0" indent="0" marL="0">
+                        <a:buNone/>
+                      </a:pPr>
+                      <a:r>
+                        <a:rPr/>
+                        <a:t>how quickly firms post vacancies for the workers they want</a:t>
+                      </a:r>
+                    </a:p>
+                  </a:txBody>
+                </a:tc>
+              </a:tr>
+              <a:tr h="0">
+                <a:tc>
+                  <a:txBody>
+                    <a:bodyPr/>
+                    <a:lstStyle/>
+                    <a:p>
+                      <a:pPr lvl="0" indent="0" marL="0">
+                        <a:buNone/>
+                      </a:pPr>
+                      <a:r>
+                        <a:rPr b="1"/>
                         <a:t>Today</a:t>
                       </a:r>
                     </a:p>
@@ -5349,32 +5583,70 @@
                       </a:pPr>
                       <a:r>
                         <a:rPr i="1"/>
-                        <a:t>Same in all scenarios:</a:t>
+                        <a:t>same in all scenarios</a:t>
                       </a:r>
                     </a:p>
+                  </a:txBody>
+                </a:tc>
+              </a:tr>
+              <a:tr h="0">
+                <a:tc>
+                  <a:txBody>
+                    <a:bodyPr/>
+                    <a:lstStyle/>
                     <a:p>
                       <a:pPr lvl="0" indent="0" marL="0">
                         <a:buNone/>
                       </a:pPr>
                       <a:r>
                         <a:rPr/>
-                        <a:t>• </a:t>
+                        <a:t>Capability</a:t>
                       </a:r>
-                      <a:r>
-                        <a:rPr i="1"/>
-                        <a:t>AI can do 14% of all work (EU: 12%)</a:t>
-                      </a:r>
-                    </a:p>
+                    </a:p>
+                  </a:txBody>
+                </a:tc>
+                <a:tc>
+                  <a:txBody>
+                    <a:bodyPr/>
+                    <a:lstStyle/>
                     <a:p>
                       <a:pPr lvl="0" indent="0" marL="0">
                         <a:buNone/>
                       </a:pPr>
                       <a:r>
                         <a:rPr/>
-                        <a:t>• </a:t>
+                        <a:t>AI can do 14% of all work (EU: 12%)</a:t>
                       </a:r>
+                    </a:p>
+                  </a:txBody>
+                </a:tc>
+              </a:tr>
+              <a:tr h="0">
+                <a:tc>
+                  <a:txBody>
+                    <a:bodyPr/>
+                    <a:lstStyle/>
+                    <a:p>
+                      <a:pPr lvl="0" indent="0" marL="0">
+                        <a:buNone/>
+                      </a:pPr>
                       <a:r>
-                        <a:rPr i="1"/>
+                        <a:rPr/>
+                        <a:t>Adoption</a:t>
+                      </a:r>
+                    </a:p>
+                  </a:txBody>
+                </a:tc>
+                <a:tc>
+                  <a:txBody>
+                    <a:bodyPr/>
+                    <a:lstStyle/>
+                    <a:p>
+                      <a:pPr lvl="0" indent="0" marL="0">
+                        <a:buNone/>
+                      </a:pPr>
+                      <a:r>
+                        <a:rPr/>
                         <a:t>of that work, 10% is actually done with AI (EU: 6%)</a:t>
                       </a:r>
                     </a:p>
@@ -5458,10 +5730,10 @@
                 <a:tableStyleId>{5C22544A-7EE6-4342-B048-85BDC9FD1C3A}</a:tableStyleId>
               </a:tblPr>
               <a:tblGrid>
-                <a:gridCol w="1587500"/>
-                <a:gridCol w="1587500"/>
-                <a:gridCol w="1587500"/>
-                <a:gridCol w="3479800"/>
+                <a:gridCol w="1397000"/>
+                <a:gridCol w="1727200"/>
+                <a:gridCol w="1435100"/>
+                <a:gridCol w="3657600"/>
               </a:tblGrid>
               <a:tr h="0">
                 <a:tc>
@@ -5533,8 +5805,52 @@
                         <a:buNone/>
                       </a:pPr>
                       <a:r>
+                        <a:rPr b="1"/>
+                        <a:t>Use of AI</a:t>
+                      </a:r>
+                    </a:p>
+                  </a:txBody>
+                </a:tc>
+                <a:tc>
+                  <a:txBody>
+                    <a:bodyPr/>
+                    <a:lstStyle/>
+                    <a:p>
+                      <a:endParaRPr/>
+                    </a:p>
+                  </a:txBody>
+                </a:tc>
+                <a:tc>
+                  <a:txBody>
+                    <a:bodyPr/>
+                    <a:lstStyle/>
+                    <a:p>
+                      <a:endParaRPr/>
+                    </a:p>
+                  </a:txBody>
+                </a:tc>
+                <a:tc>
+                  <a:txBody>
+                    <a:bodyPr/>
+                    <a:lstStyle/>
+                    <a:p>
+                      <a:endParaRPr/>
+                    </a:p>
+                  </a:txBody>
+                </a:tc>
+              </a:tr>
+              <a:tr h="0">
+                <a:tc>
+                  <a:txBody>
+                    <a:bodyPr/>
+                    <a:lstStyle/>
+                    <a:p>
+                      <a:pPr lvl="0" indent="0" marL="0">
+                        <a:buNone/>
+                      </a:pPr>
+                      <a:r>
                         <a:rPr/>
-                        <a:t>capability 2030</a:t>
+                        <a:t>Capability</a:t>
                       </a:r>
                     </a:p>
                   </a:txBody>
@@ -5596,7 +5912,7 @@
                       </a:pPr>
                       <a:r>
                         <a:rPr/>
-                        <a:t>adoption 2030</a:t>
+                        <a:t>Adoption</a:t>
                       </a:r>
                     </a:p>
                   </a:txBody>
@@ -5657,8 +5973,52 @@
                         <a:buNone/>
                       </a:pPr>
                       <a:r>
+                        <a:rPr b="1"/>
+                        <a:t>Effect on tasks</a:t>
+                      </a:r>
+                    </a:p>
+                  </a:txBody>
+                </a:tc>
+                <a:tc>
+                  <a:txBody>
+                    <a:bodyPr/>
+                    <a:lstStyle/>
+                    <a:p>
+                      <a:endParaRPr/>
+                    </a:p>
+                  </a:txBody>
+                </a:tc>
+                <a:tc>
+                  <a:txBody>
+                    <a:bodyPr/>
+                    <a:lstStyle/>
+                    <a:p>
+                      <a:endParaRPr/>
+                    </a:p>
+                  </a:txBody>
+                </a:tc>
+                <a:tc>
+                  <a:txBody>
+                    <a:bodyPr/>
+                    <a:lstStyle/>
+                    <a:p>
+                      <a:endParaRPr/>
+                    </a:p>
+                  </a:txBody>
+                </a:tc>
+              </a:tr>
+              <a:tr h="0">
+                <a:tc>
+                  <a:txBody>
+                    <a:bodyPr/>
+                    <a:lstStyle/>
+                    <a:p>
+                      <a:pPr lvl="0" indent="0" marL="0">
+                        <a:buNone/>
+                      </a:pPr>
+                      <a:r>
                         <a:rPr/>
-                        <a:t>automation</a:t>
+                        <a:t>Automation</a:t>
                       </a:r>
                     </a:p>
                   </a:txBody>
@@ -5703,7 +6063,7 @@
                       </a:pPr>
                       <a:r>
                         <a:rPr/>
-                        <a:t>usage share is an upper bound</a:t>
+                        <a:t>data counts iterations as automation</a:t>
                       </a:r>
                     </a:p>
                   </a:txBody>
@@ -5720,7 +6080,7 @@
                       </a:pPr>
                       <a:r>
                         <a:rPr/>
-                        <a:t>new tasks</a:t>
+                        <a:t>New tasks</a:t>
                       </a:r>
                     </a:p>
                   </a:txBody>
@@ -5765,7 +6125,7 @@
                       </a:pPr>
                       <a:r>
                         <a:rPr/>
-                        <a:t>EU evidence</a:t>
+                        <a:t>historically: more new tasks</a:t>
                       </a:r>
                     </a:p>
                   </a:txBody>
@@ -5782,7 +6142,7 @@
                       </a:pPr>
                       <a:r>
                         <a:rPr/>
-                        <a:t>gain per task</a:t>
+                        <a:t>Gain per task</a:t>
                       </a:r>
                     </a:p>
                   </a:txBody>
@@ -5828,6 +6188,174 @@
                       <a:r>
                         <a:rPr/>
                         <a:t>property of the tool</a:t>
+                      </a:r>
+                    </a:p>
+                  </a:txBody>
+                </a:tc>
+              </a:tr>
+              <a:tr h="0">
+                <a:tc>
+                  <a:txBody>
+                    <a:bodyPr/>
+                    <a:lstStyle/>
+                    <a:p>
+                      <a:pPr lvl="0" indent="0" marL="0">
+                        <a:buNone/>
+                      </a:pPr>
+                      <a:r>
+                        <a:rPr b="1"/>
+                        <a:t>Finding new jobs</a:t>
+                      </a:r>
+                    </a:p>
+                  </a:txBody>
+                </a:tc>
+                <a:tc>
+                  <a:txBody>
+                    <a:bodyPr/>
+                    <a:lstStyle/>
+                    <a:p>
+                      <a:endParaRPr/>
+                    </a:p>
+                  </a:txBody>
+                </a:tc>
+                <a:tc>
+                  <a:txBody>
+                    <a:bodyPr/>
+                    <a:lstStyle/>
+                    <a:p>
+                      <a:endParaRPr/>
+                    </a:p>
+                  </a:txBody>
+                </a:tc>
+                <a:tc>
+                  <a:txBody>
+                    <a:bodyPr/>
+                    <a:lstStyle/>
+                    <a:p>
+                      <a:endParaRPr/>
+                    </a:p>
+                  </a:txBody>
+                </a:tc>
+              </a:tr>
+              <a:tr h="0">
+                <a:tc>
+                  <a:txBody>
+                    <a:bodyPr/>
+                    <a:lstStyle/>
+                    <a:p>
+                      <a:pPr lvl="0" indent="0" marL="0">
+                        <a:buNone/>
+                      </a:pPr>
+                      <a:r>
+                        <a:rPr/>
+                        <a:t>Switching</a:t>
+                      </a:r>
+                    </a:p>
+                  </a:txBody>
+                </a:tc>
+                <a:tc>
+                  <a:txBody>
+                    <a:bodyPr/>
+                    <a:lstStyle/>
+                    <a:p>
+                      <a:pPr lvl="0" indent="0" marL="0">
+                        <a:buNone/>
+                      </a:pPr>
+                      <a:r>
+                        <a:rPr/>
+                        <a:t>3 / 6 / 13 months</a:t>
+                      </a:r>
+                    </a:p>
+                  </a:txBody>
+                </a:tc>
+                <a:tc>
+                  <a:txBody>
+                    <a:bodyPr/>
+                    <a:lstStyle/>
+                    <a:p>
+                      <a:pPr lvl="0" indent="0" marL="0">
+                        <a:buNone/>
+                      </a:pPr>
+                      <a:r>
+                        <a:rPr/>
+                        <a:t>same</a:t>
+                      </a:r>
+                    </a:p>
+                  </a:txBody>
+                </a:tc>
+                <a:tc>
+                  <a:txBody>
+                    <a:bodyPr/>
+                    <a:lstStyle/>
+                    <a:p>
+                      <a:pPr lvl="0" indent="0" marL="0">
+                        <a:buNone/>
+                      </a:pPr>
+                      <a:r>
+                        <a:rPr/>
+                        <a:t>no differences in retraining time</a:t>
+                      </a:r>
+                    </a:p>
+                  </a:txBody>
+                </a:tc>
+              </a:tr>
+              <a:tr h="0">
+                <a:tc>
+                  <a:txBody>
+                    <a:bodyPr/>
+                    <a:lstStyle/>
+                    <a:p>
+                      <a:pPr lvl="0" indent="0" marL="0">
+                        <a:buNone/>
+                      </a:pPr>
+                      <a:r>
+                        <a:rPr/>
+                        <a:t>Hiring speed</a:t>
+                      </a:r>
+                    </a:p>
+                  </a:txBody>
+                </a:tc>
+                <a:tc>
+                  <a:txBody>
+                    <a:bodyPr/>
+                    <a:lstStyle/>
+                    <a:p>
+                      <a:pPr lvl="0" indent="0" marL="0">
+                        <a:buNone/>
+                      </a:pPr>
+                      <a:r>
+                        <a:rPr/>
+                        <a:t>7 / 2.5 / 1 months</a:t>
+                      </a:r>
+                    </a:p>
+                  </a:txBody>
+                </a:tc>
+                <a:tc>
+                  <a:txBody>
+                    <a:bodyPr/>
+                    <a:lstStyle/>
+                    <a:p>
+                      <a:pPr lvl="0" indent="0" marL="0">
+                        <a:buNone/>
+                      </a:pPr>
+                      <a:r>
+                        <a:rPr/>
+                        <a:t>same</a:t>
+                      </a:r>
+                    </a:p>
+                  </a:txBody>
+                </a:tc>
+                <a:tc>
+                  <a:txBody>
+                    <a:bodyPr/>
+                    <a:lstStyle/>
+                    <a:p>
+                      <a:pPr lvl="0" indent="0" marL="0">
+                        <a:buNone/>
+                      </a:pPr>
+                      <a:r>
+                        <a:rPr/>
+                        <a:t>no data to estimate</a:t>
                       </a:r>
                     </a:p>
                   </a:txBody>

</xml_diff>